<commit_message>
Add live demo endpoint to implementation slide
</commit_message>
<xml_diff>
--- a/docs/presentation/decoration-preview-service_4b541b44.pptx
+++ b/docs/presentation/decoration-preview-service_4b541b44.pptx
@@ -6810,6 +6810,45 @@
           </a:p>
         </p:txBody>
       </p:sp>
+      <p:sp>
+        <p:nvSpPr>
+          <p:cNvPr id="60" name="Text 54"/>
+          <p:cNvSpPr txBox="1"/>
+          <p:nvPr/>
+        </p:nvSpPr>
+        <p:spPr>
+          <a:xfrm>
+            <a:off x="6156770" y="6172200"/>
+            <a:ext cx="5447348" cy="203200"/>
+          </a:xfrm>
+          <a:prstGeom prst="rect">
+            <a:avLst/>
+          </a:prstGeom>
+          <a:noFill/>
+          <a:ln/>
+        </p:spPr>
+        <p:txBody>
+          <a:bodyPr wrap="none" lIns="0" tIns="0" rIns="0" bIns="0" rtlCol="0" anchor="ctr"/>
+          <a:lstStyle/>
+          <a:p>
+            <a:pPr algn="r" indent="0" marL="0">
+              <a:buNone/>
+            </a:pPr>
+            <a:r>
+              <a:rPr lang="en-US" sz="1097" dirty="0">
+                <a:solidFill>
+                  <a:srgbClr val="94A3B8"/>
+                </a:solidFill>
+                <a:latin typeface="Century Gothic" pitchFamily="34" charset="0"/>
+                <a:ea typeface="Century Gothic" pitchFamily="34" charset="-122"/>
+                <a:cs typeface="Century Gothic" pitchFamily="34" charset="-120"/>
+              </a:rPr>
+              <a:t>Live demo endpoint: http://decoration-preview-alb-1021450355.eu-central-1.elb.amazonaws.com/</a:t>
+            </a:r>
+            <a:endParaRPr lang="en-US" sz="1097" dirty="0"/>
+          </a:p>
+        </p:txBody>
+      </p:sp>
     </p:spTree>
   </p:cSld>
   <p:clrMapOvr>

</xml_diff>

<commit_message>
Add presenter details to title slide
</commit_message>
<xml_diff>
--- a/docs/presentation/decoration-preview-service_4b541b44.pptx
+++ b/docs/presentation/decoration-preview-service_4b541b44.pptx
@@ -3122,7 +3122,7 @@
                 <a:ea typeface="Century Gothic" pitchFamily="34" charset="-122"/>
                 <a:cs typeface="Century Gothic" pitchFamily="34" charset="-120"/>
               </a:rPr>
-              <a:t>Lead Engineer</a:t>
+              <a:t>Patrick Klie</a:t>
             </a:r>
             <a:endParaRPr lang="en-US" sz="4788" dirty="0"/>
           </a:p>
@@ -3243,7 +3243,7 @@
                 <a:ea typeface="Century Gothic" pitchFamily="34" charset="-122"/>
                 <a:cs typeface="Century Gothic" pitchFamily="34" charset="-120"/>
               </a:rPr>
-              <a:t>30-Minute Presentation</a:t>
+              <a:t>Lead Engineer, Creative Tooling interview</a:t>
             </a:r>
             <a:endParaRPr lang="en-US" sz="1496" dirty="0"/>
           </a:p>
@@ -3306,6 +3306,45 @@
                 <a:cs typeface="Century Gothic" pitchFamily="34" charset="-120"/>
               </a:rPr>
               <a:t>Engineering · Design · Senior Leadership</a:t>
+            </a:r>
+            <a:endParaRPr lang="en-US" sz="1496" dirty="0"/>
+          </a:p>
+        </p:txBody>
+      </p:sp>
+      <p:sp>
+        <p:nvSpPr>
+          <p:cNvPr id="11" name="Text 7"/>
+          <p:cNvSpPr txBox="1"/>
+          <p:nvPr/>
+        </p:nvSpPr>
+        <p:spPr>
+          <a:xfrm>
+            <a:off x="4110847" y="5375288"/>
+            <a:ext cx="3939826" cy="228600"/>
+          </a:xfrm>
+          <a:prstGeom prst="rect">
+            <a:avLst/>
+          </a:prstGeom>
+          <a:noFill/>
+          <a:ln/>
+        </p:spPr>
+        <p:txBody>
+          <a:bodyPr wrap="square" lIns="0" tIns="0" rIns="0" bIns="0" rtlCol="0" anchor="ctr"/>
+          <a:lstStyle/>
+          <a:p>
+            <a:pPr algn="ctr" indent="0" marL="0">
+              <a:buNone/>
+            </a:pPr>
+            <a:r>
+              <a:rPr lang="en-US" sz="1496" dirty="0">
+                <a:solidFill>
+                  <a:srgbClr val="94A3B8"/>
+                </a:solidFill>
+                <a:latin typeface="Century Gothic" pitchFamily="34" charset="0"/>
+                <a:ea typeface="Century Gothic" pitchFamily="34" charset="-122"/>
+                <a:cs typeface="Century Gothic" pitchFamily="34" charset="-120"/>
+              </a:rPr>
+              <a:t>8 April 2026</a:t>
             </a:r>
             <a:endParaRPr lang="en-US" sz="1496" dirty="0"/>
           </a:p>

</xml_diff>

<commit_message>
Refine title slide layout
</commit_message>
<xml_diff>
--- a/docs/presentation/decoration-preview-service_4b541b44.pptx
+++ b/docs/presentation/decoration-preview-service_4b541b44.pptx
@@ -3130,6 +3130,84 @@
       </p:sp>
       <p:sp>
         <p:nvSpPr>
+          <p:cNvPr id="11" name="Text 7"/>
+          <p:cNvSpPr txBox="1"/>
+          <p:nvPr/>
+        </p:nvSpPr>
+        <p:spPr>
+          <a:xfrm>
+            <a:off x="2837688" y="3702075"/>
+            <a:ext cx="6486144" cy="254000"/>
+          </a:xfrm>
+          <a:prstGeom prst="rect">
+            <a:avLst/>
+          </a:prstGeom>
+          <a:noFill/>
+          <a:ln/>
+        </p:spPr>
+        <p:txBody>
+          <a:bodyPr wrap="square" lIns="0" tIns="0" rIns="0" bIns="0" rtlCol="0" anchor="ctr"/>
+          <a:lstStyle/>
+          <a:p>
+            <a:pPr algn="ctr" indent="0" marL="0">
+              <a:buNone/>
+            </a:pPr>
+            <a:r>
+              <a:rPr lang="en-US" sz="1795" dirty="0">
+                <a:solidFill>
+                  <a:srgbClr val="94A3B8"/>
+                </a:solidFill>
+                <a:latin typeface="Century Gothic" pitchFamily="34" charset="0"/>
+                <a:ea typeface="Century Gothic" pitchFamily="34" charset="-122"/>
+                <a:cs typeface="Century Gothic" pitchFamily="34" charset="-120"/>
+              </a:rPr>
+              <a:t>Lead Engineer, Creative Tooling interview</a:t>
+            </a:r>
+            <a:endParaRPr lang="en-US" sz="1795" dirty="0"/>
+          </a:p>
+        </p:txBody>
+      </p:sp>
+      <p:sp>
+        <p:nvSpPr>
+          <p:cNvPr id="12" name="Text 8"/>
+          <p:cNvSpPr txBox="1"/>
+          <p:nvPr/>
+        </p:nvSpPr>
+        <p:spPr>
+          <a:xfrm>
+            <a:off x="4110847" y="3966075"/>
+            <a:ext cx="3939826" cy="228600"/>
+          </a:xfrm>
+          <a:prstGeom prst="rect">
+            <a:avLst/>
+          </a:prstGeom>
+          <a:noFill/>
+          <a:ln/>
+        </p:spPr>
+        <p:txBody>
+          <a:bodyPr wrap="square" lIns="0" tIns="0" rIns="0" bIns="0" rtlCol="0" anchor="ctr"/>
+          <a:lstStyle/>
+          <a:p>
+            <a:pPr algn="ctr" indent="0" marL="0">
+              <a:buNone/>
+            </a:pPr>
+            <a:r>
+              <a:rPr lang="en-US" sz="1496" dirty="0">
+                <a:solidFill>
+                  <a:srgbClr val="64748B"/>
+                </a:solidFill>
+                <a:latin typeface="Century Gothic" pitchFamily="34" charset="0"/>
+                <a:ea typeface="Century Gothic" pitchFamily="34" charset="-122"/>
+                <a:cs typeface="Century Gothic" pitchFamily="34" charset="-120"/>
+              </a:rPr>
+              <a:t>8 April 2026</a:t>
+            </a:r>
+            <a:endParaRPr lang="en-US" sz="1496" dirty="0"/>
+          </a:p>
+        </p:txBody>
+      </p:sp>
+      <p:sp>
+        <p:nvSpPr>
           <p:cNvPr id="5" name="Shape 3"/>
           <p:cNvSpPr/>
           <p:nvPr/>
@@ -3243,7 +3321,7 @@
                 <a:ea typeface="Century Gothic" pitchFamily="34" charset="-122"/>
                 <a:cs typeface="Century Gothic" pitchFamily="34" charset="-120"/>
               </a:rPr>
-              <a:t>Lead Engineer, Creative Tooling interview</a:t>
+              <a:t>30-Minute Presentation</a:t>
             </a:r>
             <a:endParaRPr lang="en-US" sz="1496" dirty="0"/>
           </a:p>
@@ -3306,45 +3384,6 @@
                 <a:cs typeface="Century Gothic" pitchFamily="34" charset="-120"/>
               </a:rPr>
               <a:t>Engineering · Design · Senior Leadership</a:t>
-            </a:r>
-            <a:endParaRPr lang="en-US" sz="1496" dirty="0"/>
-          </a:p>
-        </p:txBody>
-      </p:sp>
-      <p:sp>
-        <p:nvSpPr>
-          <p:cNvPr id="11" name="Text 7"/>
-          <p:cNvSpPr txBox="1"/>
-          <p:nvPr/>
-        </p:nvSpPr>
-        <p:spPr>
-          <a:xfrm>
-            <a:off x="4110847" y="5375288"/>
-            <a:ext cx="3939826" cy="228600"/>
-          </a:xfrm>
-          <a:prstGeom prst="rect">
-            <a:avLst/>
-          </a:prstGeom>
-          <a:noFill/>
-          <a:ln/>
-        </p:spPr>
-        <p:txBody>
-          <a:bodyPr wrap="square" lIns="0" tIns="0" rIns="0" bIns="0" rtlCol="0" anchor="ctr"/>
-          <a:lstStyle/>
-          <a:p>
-            <a:pPr algn="ctr" indent="0" marL="0">
-              <a:buNone/>
-            </a:pPr>
-            <a:r>
-              <a:rPr lang="en-US" sz="1496" dirty="0">
-                <a:solidFill>
-                  <a:srgbClr val="94A3B8"/>
-                </a:solidFill>
-                <a:latin typeface="Century Gothic" pitchFamily="34" charset="0"/>
-                <a:ea typeface="Century Gothic" pitchFamily="34" charset="-122"/>
-                <a:cs typeface="Century Gothic" pitchFamily="34" charset="-120"/>
-              </a:rPr>
-              <a:t>8 April 2026</a:t>
             </a:r>
             <a:endParaRPr lang="en-US" sz="1496" dirty="0"/>
           </a:p>

</xml_diff>

<commit_message>
Adjust title slide spacing and alignment
</commit_message>
<xml_diff>
--- a/docs/presentation/decoration-preview-service_4b541b44.pptx
+++ b/docs/presentation/decoration-preview-service_4b541b44.pptx
@@ -3032,7 +3032,7 @@
           <a:bodyPr wrap="square" lIns="0" tIns="0" rIns="0" bIns="0" rtlCol="0" anchor="ctr"/>
           <a:lstStyle/>
           <a:p>
-            <a:pPr algn="l" indent="0" marL="0">
+            <a:pPr algn="ctr" indent="0" marL="0">
               <a:buNone/>
             </a:pPr>
             <a:r>
@@ -3044,7 +3044,7 @@
                 <a:ea typeface="Century Gothic" pitchFamily="34" charset="-122"/>
                 <a:cs typeface="Century Gothic" pitchFamily="34" charset="-120"/>
               </a:rPr>
-              <a:t>Case Assignment Presentation</a:t>
+              <a:t>CASE ASSIGNMENT PRESENTATION</a:t>
             </a:r>
             <a:endParaRPr lang="en-US" sz="1496" dirty="0"/>
           </a:p>
@@ -3136,7 +3136,7 @@
         </p:nvSpPr>
         <p:spPr>
           <a:xfrm>
-            <a:off x="2837688" y="3702075"/>
+            <a:off x="2837688" y="3822075"/>
             <a:ext cx="6486144" cy="254000"/>
           </a:xfrm>
           <a:prstGeom prst="rect">
@@ -3175,7 +3175,7 @@
         </p:nvSpPr>
         <p:spPr>
           <a:xfrm>
-            <a:off x="4110847" y="3966075"/>
+            <a:off x="4110847" y="4126075"/>
             <a:ext cx="3939826" cy="228600"/>
           </a:xfrm>
           <a:prstGeom prst="rect">
@@ -3214,7 +3214,7 @@
         </p:nvSpPr>
         <p:spPr>
           <a:xfrm>
-            <a:off x="4813935" y="4156075"/>
+            <a:off x="4813935" y="4476075"/>
             <a:ext cx="2533650" cy="19050"/>
           </a:xfrm>
           <a:prstGeom prst="rect">
@@ -3234,7 +3234,7 @@
         </p:nvSpPr>
         <p:spPr>
           <a:xfrm>
-            <a:off x="2109264" y="4429125"/>
+            <a:off x="2109264" y="4749125"/>
             <a:ext cx="7942993" cy="254000"/>
           </a:xfrm>
           <a:prstGeom prst="rect">

</xml_diff>

<commit_message>
Rebalance title slide spacing
</commit_message>
<xml_diff>
--- a/docs/presentation/decoration-preview-service_4b541b44.pptx
+++ b/docs/presentation/decoration-preview-service_4b541b44.pptx
@@ -3136,7 +3136,7 @@
         </p:nvSpPr>
         <p:spPr>
           <a:xfrm>
-            <a:off x="2837688" y="3922075"/>
+            <a:off x="2837688" y="4022075"/>
             <a:ext cx="6486144" cy="254000"/>
           </a:xfrm>
           <a:prstGeom prst="rect">
@@ -3175,7 +3175,7 @@
         </p:nvSpPr>
         <p:spPr>
           <a:xfrm>
-            <a:off x="4110847" y="4126075"/>
+            <a:off x="4110847" y="4326075"/>
             <a:ext cx="3939826" cy="228600"/>
           </a:xfrm>
           <a:prstGeom prst="rect">
@@ -3214,7 +3214,7 @@
         </p:nvSpPr>
         <p:spPr>
           <a:xfrm>
-            <a:off x="4813935" y="4476075"/>
+            <a:off x="4813935" y="4706075"/>
             <a:ext cx="2533650" cy="19050"/>
           </a:xfrm>
           <a:prstGeom prst="rect">
@@ -3234,7 +3234,7 @@
         </p:nvSpPr>
         <p:spPr>
           <a:xfrm>
-            <a:off x="2109264" y="4749125"/>
+            <a:off x="2109264" y="5019125"/>
             <a:ext cx="7942993" cy="254000"/>
           </a:xfrm>
           <a:prstGeom prst="rect">
@@ -3280,7 +3280,7 @@
         </p:blipFill>
         <p:spPr>
           <a:xfrm>
-            <a:off x="2619161" y="5064125"/>
+            <a:off x="2619161" y="5334125"/>
             <a:ext cx="177356" cy="177800"/>
           </a:xfrm>
           <a:prstGeom prst="rect">
@@ -3296,7 +3296,7 @@
         </p:nvSpPr>
         <p:spPr>
           <a:xfrm>
-            <a:off x="2872526" y="5038725"/>
+            <a:off x="2872526" y="5308725"/>
             <a:ext cx="2242280" cy="228600"/>
           </a:xfrm>
           <a:prstGeom prst="rect">
@@ -3342,7 +3342,7 @@
         </p:blipFill>
         <p:spPr>
           <a:xfrm>
-            <a:off x="5418844" y="5064125"/>
+            <a:off x="5418844" y="5334125"/>
             <a:ext cx="177356" cy="177800"/>
           </a:xfrm>
           <a:prstGeom prst="rect">
@@ -3358,7 +3358,7 @@
         </p:nvSpPr>
         <p:spPr>
           <a:xfrm>
-            <a:off x="5672209" y="5038725"/>
+            <a:off x="5672209" y="5308725"/>
             <a:ext cx="3870150" cy="228600"/>
           </a:xfrm>
           <a:prstGeom prst="rect">

</xml_diff>